<commit_message>
Point repository URLs at github.com/bilal-feroz/PluginFence
The Plugin-Fence repository was deleted; the CI badge, plugin vendor URL and
pitch deck all pointed at a URL that now 404s.

Co-Authored-By: Claude Opus 5 <noreply@anthropic.com>
</commit_message>
<xml_diff>
--- a/docs/PluginFence-pitch.pptx
+++ b/docs/PluginFence-pitch.pptx
@@ -2462,7 +2462,7 @@
                 <a:ea typeface="Calibri" pitchFamily="34" charset="-122"/>
                 <a:cs typeface="Calibri" pitchFamily="34" charset="-120"/>
               </a:rPr>
-              <a:t>github.com/bilal-feroz/Plugin-Fence   ·   IntelliJ Platform 2026.2   ·   JVM agent + Kotlin plugin   ·   MIT</a:t>
+              <a:t>github.com/bilal-feroz/PluginFence   ·   IntelliJ Platform 2026.2   ·   JVM agent + Kotlin plugin   ·   MIT</a:t>
             </a:r>
             <a:endParaRPr lang="en-US" sz="1100" dirty="0"/>
           </a:p>
@@ -9955,7 +9955,7 @@
                 <a:ea typeface="Calibri" pitchFamily="34" charset="-122"/>
                 <a:cs typeface="Calibri" pitchFamily="34" charset="-120"/>
               </a:rPr>
-              <a:t>github.com/bilal-feroz/Plugin-Fence   ·   MIT</a:t>
+              <a:t>github.com/bilal-feroz/PluginFence   ·   MIT</a:t>
             </a:r>
             <a:endParaRPr lang="en-US" sz="1200" dirty="0"/>
           </a:p>

</xml_diff>